<commit_message>
Design: per-attribute tokens replace the single static MLP token
Attributes are ID-addressed like series variables, so a new attribute is a new
ID rather than a change to the input layer, a missing attribute is an ABSENT
TOKEN rather than a zero, and attribute masking becomes identical to variable
masking. Costs +13% tokens (196 -> 222).

Driven by global-scale constraints rather than CAMELS: ~40,000 stations, many
curated statics unreliable or missing, DEM the only globally consistent input
and only at 30 m. Records the open question of whether the architecture should
preferentially rely on DEM-derived features, and that the honest first step is
to ablate curated statics at inference and measure the drop.

Deck slide added recording the six design decisions this session's experiments
forced, each with the measurement that contradicted the prior design.
</commit_message>
<xml_diff>
--- a/docs/StefaNP_design.pptx
+++ b/docs/StefaNP_design.pptx
@@ -21,6 +21,7 @@
     <p:sldId id="269" r:id="rId20"/>
     <p:sldId id="270" r:id="rId21"/>
     <p:sldId id="271" r:id="rId22"/>
+    <p:sldId id="272" r:id="rId23"/>
   </p:sldIdLst>
   <p:sldSz cx="12191695" cy="6858000" type="screen4x3"/>
   <p:notesSz cx="6858000" cy="9144000"/>
@@ -16632,6 +16633,2200 @@
 </p:sld>
 </file>
 
+<file path=ppt/slides/slide17.xml><?xml version="1.0" encoding="utf-8"?>
+<p:sld xmlns:a="http://schemas.openxmlformats.org/drawingml/2006/main" xmlns:p="http://schemas.openxmlformats.org/presentationml/2006/main" xmlns:r="http://schemas.openxmlformats.org/officeDocument/2006/relationships">
+  <p:cSld>
+    <p:spTree>
+      <p:nvGrpSpPr>
+        <p:cNvPr id="1" name=""/>
+        <p:cNvGrpSpPr/>
+        <p:nvPr/>
+      </p:nvGrpSpPr>
+      <p:grpSpPr/>
+      <p:sp>
+        <p:nvSpPr>
+          <p:cNvPr id="2" name="Rectangle 1"/>
+          <p:cNvSpPr/>
+          <p:nvPr/>
+        </p:nvSpPr>
+        <p:spPr>
+          <a:xfrm>
+            <a:off x="0" y="0"/>
+            <a:ext cx="12191695" cy="54864"/>
+          </a:xfrm>
+          <a:prstGeom prst="rect">
+            <a:avLst/>
+          </a:prstGeom>
+          <a:solidFill>
+            <a:srgbClr val="0B5F8A"/>
+          </a:solidFill>
+          <a:ln>
+            <a:noFill/>
+          </a:ln>
+          <a:effectLst/>
+        </p:spPr>
+        <p:style>
+          <a:lnRef idx="1">
+            <a:schemeClr val="accent1"/>
+          </a:lnRef>
+          <a:fillRef idx="3">
+            <a:schemeClr val="accent1"/>
+          </a:fillRef>
+          <a:effectRef idx="2">
+            <a:schemeClr val="accent1"/>
+          </a:effectRef>
+          <a:fontRef idx="minor">
+            <a:schemeClr val="lt1"/>
+          </a:fontRef>
+        </p:style>
+        <p:txBody>
+          <a:bodyPr rtlCol="0" anchor="ctr"/>
+          <a:lstStyle/>
+          <a:p/>
+        </p:txBody>
+      </p:sp>
+      <p:sp>
+        <p:nvSpPr>
+          <p:cNvPr id="3" name="TextBox 2"/>
+          <p:cNvSpPr txBox="1"/>
+          <p:nvPr/>
+        </p:nvSpPr>
+        <p:spPr>
+          <a:xfrm>
+            <a:off x="457200" y="201168"/>
+            <a:ext cx="11338560" cy="457200"/>
+          </a:xfrm>
+          <a:prstGeom prst="rect">
+            <a:avLst/>
+          </a:prstGeom>
+          <a:noFill/>
+        </p:spPr>
+        <p:txBody>
+          <a:bodyPr wrap="square">
+            <a:spAutoFit/>
+          </a:bodyPr>
+          <a:lstStyle/>
+          <a:p>
+            <a:pPr algn="l">
+              <a:spcAft>
+                <a:spcPts val="400"/>
+              </a:spcAft>
+            </a:pPr>
+            <a:r>
+              <a:rPr sz="2600" b="1" i="0">
+                <a:solidFill>
+                  <a:srgbClr val="1A1A1A"/>
+                </a:solidFill>
+                <a:latin typeface="Calibri"/>
+              </a:rPr>
+              <a:t>Design decisions forced by measurement (2026-08-24)</a:t>
+            </a:r>
+          </a:p>
+        </p:txBody>
+      </p:sp>
+      <p:sp>
+        <p:nvSpPr>
+          <p:cNvPr id="4" name="TextBox 3"/>
+          <p:cNvSpPr txBox="1"/>
+          <p:nvPr/>
+        </p:nvSpPr>
+        <p:spPr>
+          <a:xfrm>
+            <a:off x="457200" y="713232"/>
+            <a:ext cx="11338560" cy="365760"/>
+          </a:xfrm>
+          <a:prstGeom prst="rect">
+            <a:avLst/>
+          </a:prstGeom>
+          <a:noFill/>
+        </p:spPr>
+        <p:txBody>
+          <a:bodyPr wrap="square">
+            <a:spAutoFit/>
+          </a:bodyPr>
+          <a:lstStyle/>
+          <a:p>
+            <a:pPr algn="l">
+              <a:spcAft>
+                <a:spcPts val="400"/>
+              </a:spcAft>
+            </a:pPr>
+            <a:r>
+              <a:rPr sz="1300" b="0" i="0">
+                <a:solidFill>
+                  <a:srgbClr val="5A5F66"/>
+                </a:solidFill>
+                <a:latin typeface="Calibri"/>
+              </a:rPr>
+              <a:t>Each was found by an experiment contradicting the design, not by reasoning about it</a:t>
+            </a:r>
+          </a:p>
+        </p:txBody>
+      </p:sp>
+      <p:sp>
+        <p:nvSpPr>
+          <p:cNvPr id="5" name="Rectangle 4"/>
+          <p:cNvSpPr/>
+          <p:nvPr/>
+        </p:nvSpPr>
+        <p:spPr>
+          <a:xfrm>
+            <a:off x="457200" y="1143000"/>
+            <a:ext cx="3108960" cy="566928"/>
+          </a:xfrm>
+          <a:prstGeom prst="rect">
+            <a:avLst/>
+          </a:prstGeom>
+          <a:solidFill>
+            <a:srgbClr val="0B5F8A"/>
+          </a:solidFill>
+          <a:ln>
+            <a:noFill/>
+          </a:ln>
+          <a:effectLst/>
+        </p:spPr>
+        <p:style>
+          <a:lnRef idx="1">
+            <a:schemeClr val="accent1"/>
+          </a:lnRef>
+          <a:fillRef idx="3">
+            <a:schemeClr val="accent1"/>
+          </a:fillRef>
+          <a:effectRef idx="2">
+            <a:schemeClr val="accent1"/>
+          </a:effectRef>
+          <a:fontRef idx="minor">
+            <a:schemeClr val="lt1"/>
+          </a:fontRef>
+        </p:style>
+        <p:txBody>
+          <a:bodyPr rtlCol="0" anchor="ctr"/>
+          <a:lstStyle/>
+          <a:p/>
+        </p:txBody>
+      </p:sp>
+      <p:sp>
+        <p:nvSpPr>
+          <p:cNvPr id="6" name="TextBox 5"/>
+          <p:cNvSpPr txBox="1"/>
+          <p:nvPr/>
+        </p:nvSpPr>
+        <p:spPr>
+          <a:xfrm>
+            <a:off x="512064" y="1170432"/>
+            <a:ext cx="2999232" cy="566928"/>
+          </a:xfrm>
+          <a:prstGeom prst="rect">
+            <a:avLst/>
+          </a:prstGeom>
+          <a:noFill/>
+        </p:spPr>
+        <p:txBody>
+          <a:bodyPr wrap="square">
+            <a:spAutoFit/>
+          </a:bodyPr>
+          <a:lstStyle/>
+          <a:p>
+            <a:pPr algn="l">
+              <a:spcAft>
+                <a:spcPts val="400"/>
+              </a:spcAft>
+            </a:pPr>
+            <a:r>
+              <a:rPr sz="950" b="1" i="0">
+                <a:solidFill>
+                  <a:srgbClr val="FFFFFF"/>
+                </a:solidFill>
+                <a:latin typeface="Calibri"/>
+              </a:rPr>
+              <a:t>decision</a:t>
+            </a:r>
+          </a:p>
+        </p:txBody>
+      </p:sp>
+      <p:sp>
+        <p:nvSpPr>
+          <p:cNvPr id="7" name="Rectangle 6"/>
+          <p:cNvSpPr/>
+          <p:nvPr/>
+        </p:nvSpPr>
+        <p:spPr>
+          <a:xfrm>
+            <a:off x="3566160" y="1143000"/>
+            <a:ext cx="4114800" cy="566928"/>
+          </a:xfrm>
+          <a:prstGeom prst="rect">
+            <a:avLst/>
+          </a:prstGeom>
+          <a:solidFill>
+            <a:srgbClr val="0B5F8A"/>
+          </a:solidFill>
+          <a:ln>
+            <a:noFill/>
+          </a:ln>
+          <a:effectLst/>
+        </p:spPr>
+        <p:style>
+          <a:lnRef idx="1">
+            <a:schemeClr val="accent1"/>
+          </a:lnRef>
+          <a:fillRef idx="3">
+            <a:schemeClr val="accent1"/>
+          </a:fillRef>
+          <a:effectRef idx="2">
+            <a:schemeClr val="accent1"/>
+          </a:effectRef>
+          <a:fontRef idx="minor">
+            <a:schemeClr val="lt1"/>
+          </a:fontRef>
+        </p:style>
+        <p:txBody>
+          <a:bodyPr rtlCol="0" anchor="ctr"/>
+          <a:lstStyle/>
+          <a:p/>
+        </p:txBody>
+      </p:sp>
+      <p:sp>
+        <p:nvSpPr>
+          <p:cNvPr id="8" name="TextBox 7"/>
+          <p:cNvSpPr txBox="1"/>
+          <p:nvPr/>
+        </p:nvSpPr>
+        <p:spPr>
+          <a:xfrm>
+            <a:off x="3621024" y="1170432"/>
+            <a:ext cx="4005072" cy="566928"/>
+          </a:xfrm>
+          <a:prstGeom prst="rect">
+            <a:avLst/>
+          </a:prstGeom>
+          <a:noFill/>
+        </p:spPr>
+        <p:txBody>
+          <a:bodyPr wrap="square">
+            <a:spAutoFit/>
+          </a:bodyPr>
+          <a:lstStyle/>
+          <a:p>
+            <a:pPr algn="l">
+              <a:spcAft>
+                <a:spcPts val="400"/>
+              </a:spcAft>
+            </a:pPr>
+            <a:r>
+              <a:rPr sz="950" b="1" i="0">
+                <a:solidFill>
+                  <a:srgbClr val="FFFFFF"/>
+                </a:solidFill>
+                <a:latin typeface="Calibri"/>
+              </a:rPr>
+              <a:t>why</a:t>
+            </a:r>
+          </a:p>
+        </p:txBody>
+      </p:sp>
+      <p:sp>
+        <p:nvSpPr>
+          <p:cNvPr id="9" name="Rectangle 8"/>
+          <p:cNvSpPr/>
+          <p:nvPr/>
+        </p:nvSpPr>
+        <p:spPr>
+          <a:xfrm>
+            <a:off x="7680960" y="1143000"/>
+            <a:ext cx="4023360" cy="566928"/>
+          </a:xfrm>
+          <a:prstGeom prst="rect">
+            <a:avLst/>
+          </a:prstGeom>
+          <a:solidFill>
+            <a:srgbClr val="0B5F8A"/>
+          </a:solidFill>
+          <a:ln>
+            <a:noFill/>
+          </a:ln>
+          <a:effectLst/>
+        </p:spPr>
+        <p:style>
+          <a:lnRef idx="1">
+            <a:schemeClr val="accent1"/>
+          </a:lnRef>
+          <a:fillRef idx="3">
+            <a:schemeClr val="accent1"/>
+          </a:fillRef>
+          <a:effectRef idx="2">
+            <a:schemeClr val="accent1"/>
+          </a:effectRef>
+          <a:fontRef idx="minor">
+            <a:schemeClr val="lt1"/>
+          </a:fontRef>
+        </p:style>
+        <p:txBody>
+          <a:bodyPr rtlCol="0" anchor="ctr"/>
+          <a:lstStyle/>
+          <a:p/>
+        </p:txBody>
+      </p:sp>
+      <p:sp>
+        <p:nvSpPr>
+          <p:cNvPr id="10" name="TextBox 9"/>
+          <p:cNvSpPr txBox="1"/>
+          <p:nvPr/>
+        </p:nvSpPr>
+        <p:spPr>
+          <a:xfrm>
+            <a:off x="7735824" y="1170432"/>
+            <a:ext cx="3913632" cy="566928"/>
+          </a:xfrm>
+          <a:prstGeom prst="rect">
+            <a:avLst/>
+          </a:prstGeom>
+          <a:noFill/>
+        </p:spPr>
+        <p:txBody>
+          <a:bodyPr wrap="square">
+            <a:spAutoFit/>
+          </a:bodyPr>
+          <a:lstStyle/>
+          <a:p>
+            <a:pPr algn="l">
+              <a:spcAft>
+                <a:spcPts val="400"/>
+              </a:spcAft>
+            </a:pPr>
+            <a:r>
+              <a:rPr sz="950" b="1" i="0">
+                <a:solidFill>
+                  <a:srgbClr val="FFFFFF"/>
+                </a:solidFill>
+                <a:latin typeface="Calibri"/>
+              </a:rPr>
+              <a:t>evidence</a:t>
+            </a:r>
+          </a:p>
+        </p:txBody>
+      </p:sp>
+      <p:sp>
+        <p:nvSpPr>
+          <p:cNvPr id="11" name="Rectangle 10"/>
+          <p:cNvSpPr/>
+          <p:nvPr/>
+        </p:nvSpPr>
+        <p:spPr>
+          <a:xfrm>
+            <a:off x="457200" y="1709928"/>
+            <a:ext cx="3108960" cy="566928"/>
+          </a:xfrm>
+          <a:prstGeom prst="rect">
+            <a:avLst/>
+          </a:prstGeom>
+          <a:solidFill>
+            <a:srgbClr val="F4F6F8"/>
+          </a:solidFill>
+          <a:ln>
+            <a:noFill/>
+          </a:ln>
+          <a:effectLst/>
+        </p:spPr>
+        <p:style>
+          <a:lnRef idx="1">
+            <a:schemeClr val="accent1"/>
+          </a:lnRef>
+          <a:fillRef idx="3">
+            <a:schemeClr val="accent1"/>
+          </a:fillRef>
+          <a:effectRef idx="2">
+            <a:schemeClr val="accent1"/>
+          </a:effectRef>
+          <a:fontRef idx="minor">
+            <a:schemeClr val="lt1"/>
+          </a:fontRef>
+        </p:style>
+        <p:txBody>
+          <a:bodyPr rtlCol="0" anchor="ctr"/>
+          <a:lstStyle/>
+          <a:p/>
+        </p:txBody>
+      </p:sp>
+      <p:sp>
+        <p:nvSpPr>
+          <p:cNvPr id="12" name="TextBox 11"/>
+          <p:cNvSpPr txBox="1"/>
+          <p:nvPr/>
+        </p:nvSpPr>
+        <p:spPr>
+          <a:xfrm>
+            <a:off x="512064" y="1737360"/>
+            <a:ext cx="2999232" cy="566928"/>
+          </a:xfrm>
+          <a:prstGeom prst="rect">
+            <a:avLst/>
+          </a:prstGeom>
+          <a:noFill/>
+        </p:spPr>
+        <p:txBody>
+          <a:bodyPr wrap="square">
+            <a:spAutoFit/>
+          </a:bodyPr>
+          <a:lstStyle/>
+          <a:p>
+            <a:pPr algn="l">
+              <a:spcAft>
+                <a:spcPts val="400"/>
+              </a:spcAft>
+            </a:pPr>
+            <a:r>
+              <a:rPr sz="950" b="0" i="0">
+                <a:solidFill>
+                  <a:srgbClr val="1A1A1A"/>
+                </a:solidFill>
+                <a:latin typeface="Calibri"/>
+              </a:rPr>
+              <a:t>Attributes: ONE TOKEN EACH, ID-addressed</a:t>
+            </a:r>
+          </a:p>
+          <a:p>
+            <a:pPr algn="l">
+              <a:spcAft>
+                <a:spcPts val="400"/>
+              </a:spcAft>
+            </a:pPr>
+            <a:r>
+              <a:rPr sz="950" b="0" i="0">
+                <a:solidFill>
+                  <a:srgbClr val="1A1A1A"/>
+                </a:solidFill>
+                <a:latin typeface="Calibri"/>
+              </a:rPr>
+              <a:t>(was: all 26 through one MLP)</a:t>
+            </a:r>
+          </a:p>
+        </p:txBody>
+      </p:sp>
+      <p:sp>
+        <p:nvSpPr>
+          <p:cNvPr id="13" name="Rectangle 12"/>
+          <p:cNvSpPr/>
+          <p:nvPr/>
+        </p:nvSpPr>
+        <p:spPr>
+          <a:xfrm>
+            <a:off x="3566160" y="1709928"/>
+            <a:ext cx="4114800" cy="566928"/>
+          </a:xfrm>
+          <a:prstGeom prst="rect">
+            <a:avLst/>
+          </a:prstGeom>
+          <a:solidFill>
+            <a:srgbClr val="F4F6F8"/>
+          </a:solidFill>
+          <a:ln>
+            <a:noFill/>
+          </a:ln>
+          <a:effectLst/>
+        </p:spPr>
+        <p:style>
+          <a:lnRef idx="1">
+            <a:schemeClr val="accent1"/>
+          </a:lnRef>
+          <a:fillRef idx="3">
+            <a:schemeClr val="accent1"/>
+          </a:fillRef>
+          <a:effectRef idx="2">
+            <a:schemeClr val="accent1"/>
+          </a:effectRef>
+          <a:fontRef idx="minor">
+            <a:schemeClr val="lt1"/>
+          </a:fontRef>
+        </p:style>
+        <p:txBody>
+          <a:bodyPr rtlCol="0" anchor="ctr"/>
+          <a:lstStyle/>
+          <a:p/>
+        </p:txBody>
+      </p:sp>
+      <p:sp>
+        <p:nvSpPr>
+          <p:cNvPr id="14" name="TextBox 13"/>
+          <p:cNvSpPr txBox="1"/>
+          <p:nvPr/>
+        </p:nvSpPr>
+        <p:spPr>
+          <a:xfrm>
+            <a:off x="3621024" y="1737360"/>
+            <a:ext cx="4005072" cy="566928"/>
+          </a:xfrm>
+          <a:prstGeom prst="rect">
+            <a:avLst/>
+          </a:prstGeom>
+          <a:noFill/>
+        </p:spPr>
+        <p:txBody>
+          <a:bodyPr wrap="square">
+            <a:spAutoFit/>
+          </a:bodyPr>
+          <a:lstStyle/>
+          <a:p>
+            <a:pPr algn="l">
+              <a:spcAft>
+                <a:spcPts val="400"/>
+              </a:spcAft>
+            </a:pPr>
+            <a:r>
+              <a:rPr sz="950" b="0" i="0">
+                <a:solidFill>
+                  <a:srgbClr val="1A1A1A"/>
+                </a:solidFill>
+                <a:latin typeface="Calibri"/>
+              </a:rPr>
+              <a:t>extensible to new attributes; missing becomes an</a:t>
+            </a:r>
+          </a:p>
+          <a:p>
+            <a:pPr algn="l">
+              <a:spcAft>
+                <a:spcPts val="400"/>
+              </a:spcAft>
+            </a:pPr>
+            <a:r>
+              <a:rPr sz="950" b="0" i="0">
+                <a:solidFill>
+                  <a:srgbClr val="1A1A1A"/>
+                </a:solidFill>
+                <a:latin typeface="Calibri"/>
+              </a:rPr>
+              <a:t>ABSENT TOKEN, not a zero; individually maskable</a:t>
+            </a:r>
+          </a:p>
+        </p:txBody>
+      </p:sp>
+      <p:sp>
+        <p:nvSpPr>
+          <p:cNvPr id="15" name="Rectangle 14"/>
+          <p:cNvSpPr/>
+          <p:nvPr/>
+        </p:nvSpPr>
+        <p:spPr>
+          <a:xfrm>
+            <a:off x="7680960" y="1709928"/>
+            <a:ext cx="4023360" cy="566928"/>
+          </a:xfrm>
+          <a:prstGeom prst="rect">
+            <a:avLst/>
+          </a:prstGeom>
+          <a:solidFill>
+            <a:srgbClr val="F4F6F8"/>
+          </a:solidFill>
+          <a:ln>
+            <a:noFill/>
+          </a:ln>
+          <a:effectLst/>
+        </p:spPr>
+        <p:style>
+          <a:lnRef idx="1">
+            <a:schemeClr val="accent1"/>
+          </a:lnRef>
+          <a:fillRef idx="3">
+            <a:schemeClr val="accent1"/>
+          </a:fillRef>
+          <a:effectRef idx="2">
+            <a:schemeClr val="accent1"/>
+          </a:effectRef>
+          <a:fontRef idx="minor">
+            <a:schemeClr val="lt1"/>
+          </a:fontRef>
+        </p:style>
+        <p:txBody>
+          <a:bodyPr rtlCol="0" anchor="ctr"/>
+          <a:lstStyle/>
+          <a:p/>
+        </p:txBody>
+      </p:sp>
+      <p:sp>
+        <p:nvSpPr>
+          <p:cNvPr id="16" name="TextBox 15"/>
+          <p:cNvSpPr txBox="1"/>
+          <p:nvPr/>
+        </p:nvSpPr>
+        <p:spPr>
+          <a:xfrm>
+            <a:off x="7735824" y="1737360"/>
+            <a:ext cx="3913632" cy="566928"/>
+          </a:xfrm>
+          <a:prstGeom prst="rect">
+            <a:avLst/>
+          </a:prstGeom>
+          <a:noFill/>
+        </p:spPr>
+        <p:txBody>
+          <a:bodyPr wrap="square">
+            <a:spAutoFit/>
+          </a:bodyPr>
+          <a:lstStyle/>
+          <a:p>
+            <a:pPr algn="l">
+              <a:spcAft>
+                <a:spcPts val="400"/>
+              </a:spcAft>
+            </a:pPr>
+            <a:r>
+              <a:rPr sz="950" b="0" i="0">
+                <a:solidFill>
+                  <a:srgbClr val="1B7F4B"/>
+                </a:solidFill>
+                <a:latin typeface="Calibri"/>
+              </a:rPr>
+              <a:t>+13% tokens (196 -&gt; 222). Global statics will be</a:t>
+            </a:r>
+          </a:p>
+          <a:p>
+            <a:pPr algn="l">
+              <a:spcAft>
+                <a:spcPts val="400"/>
+              </a:spcAft>
+            </a:pPr>
+            <a:r>
+              <a:rPr sz="950" b="0" i="0">
+                <a:solidFill>
+                  <a:srgbClr val="1B7F4B"/>
+                </a:solidFill>
+                <a:latin typeface="Calibri"/>
+              </a:rPr>
+              <a:t>sparse and noisy, so absent must be first-class</a:t>
+            </a:r>
+          </a:p>
+        </p:txBody>
+      </p:sp>
+      <p:sp>
+        <p:nvSpPr>
+          <p:cNvPr id="17" name="Rectangle 16"/>
+          <p:cNvSpPr/>
+          <p:nvPr/>
+        </p:nvSpPr>
+        <p:spPr>
+          <a:xfrm>
+            <a:off x="457200" y="2276856"/>
+            <a:ext cx="3108960" cy="566928"/>
+          </a:xfrm>
+          <a:prstGeom prst="rect">
+            <a:avLst/>
+          </a:prstGeom>
+          <a:solidFill>
+            <a:srgbClr val="FFFFFF"/>
+          </a:solidFill>
+          <a:ln>
+            <a:noFill/>
+          </a:ln>
+          <a:effectLst/>
+        </p:spPr>
+        <p:style>
+          <a:lnRef idx="1">
+            <a:schemeClr val="accent1"/>
+          </a:lnRef>
+          <a:fillRef idx="3">
+            <a:schemeClr val="accent1"/>
+          </a:fillRef>
+          <a:effectRef idx="2">
+            <a:schemeClr val="accent1"/>
+          </a:effectRef>
+          <a:fontRef idx="minor">
+            <a:schemeClr val="lt1"/>
+          </a:fontRef>
+        </p:style>
+        <p:txBody>
+          <a:bodyPr rtlCol="0" anchor="ctr"/>
+          <a:lstStyle/>
+          <a:p/>
+        </p:txBody>
+      </p:sp>
+      <p:sp>
+        <p:nvSpPr>
+          <p:cNvPr id="18" name="TextBox 17"/>
+          <p:cNvSpPr txBox="1"/>
+          <p:nvPr/>
+        </p:nvSpPr>
+        <p:spPr>
+          <a:xfrm>
+            <a:off x="512064" y="2304288"/>
+            <a:ext cx="2999232" cy="566928"/>
+          </a:xfrm>
+          <a:prstGeom prst="rect">
+            <a:avLst/>
+          </a:prstGeom>
+          <a:noFill/>
+        </p:spPr>
+        <p:txBody>
+          <a:bodyPr wrap="square">
+            <a:spAutoFit/>
+          </a:bodyPr>
+          <a:lstStyle/>
+          <a:p>
+            <a:pPr algn="l">
+              <a:spcAft>
+                <a:spcPts val="400"/>
+              </a:spcAft>
+            </a:pPr>
+            <a:r>
+              <a:rPr sz="950" b="0" i="0">
+                <a:solidFill>
+                  <a:srgbClr val="1A1A1A"/>
+                </a:solidFill>
+                <a:latin typeface="Calibri"/>
+              </a:rPr>
+              <a:t>The TASK DISTRIBUTION is the product,</a:t>
+            </a:r>
+          </a:p>
+          <a:p>
+            <a:pPr algn="l">
+              <a:spcAft>
+                <a:spcPts val="400"/>
+              </a:spcAft>
+            </a:pPr>
+            <a:r>
+              <a:rPr sz="950" b="0" i="0">
+                <a:solidFill>
+                  <a:srgbClr val="1A1A1A"/>
+                </a:solidFill>
+                <a:latin typeface="Calibri"/>
+              </a:rPr>
+              <a:t>not an implementation detail</a:t>
+            </a:r>
+          </a:p>
+        </p:txBody>
+      </p:sp>
+      <p:sp>
+        <p:nvSpPr>
+          <p:cNvPr id="19" name="Rectangle 18"/>
+          <p:cNvSpPr/>
+          <p:nvPr/>
+        </p:nvSpPr>
+        <p:spPr>
+          <a:xfrm>
+            <a:off x="3566160" y="2276856"/>
+            <a:ext cx="4114800" cy="566928"/>
+          </a:xfrm>
+          <a:prstGeom prst="rect">
+            <a:avLst/>
+          </a:prstGeom>
+          <a:solidFill>
+            <a:srgbClr val="FFFFFF"/>
+          </a:solidFill>
+          <a:ln>
+            <a:noFill/>
+          </a:ln>
+          <a:effectLst/>
+        </p:spPr>
+        <p:style>
+          <a:lnRef idx="1">
+            <a:schemeClr val="accent1"/>
+          </a:lnRef>
+          <a:fillRef idx="3">
+            <a:schemeClr val="accent1"/>
+          </a:fillRef>
+          <a:effectRef idx="2">
+            <a:schemeClr val="accent1"/>
+          </a:effectRef>
+          <a:fontRef idx="minor">
+            <a:schemeClr val="lt1"/>
+          </a:fontRef>
+        </p:style>
+        <p:txBody>
+          <a:bodyPr rtlCol="0" anchor="ctr"/>
+          <a:lstStyle/>
+          <a:p/>
+        </p:txBody>
+      </p:sp>
+      <p:sp>
+        <p:nvSpPr>
+          <p:cNvPr id="20" name="TextBox 19"/>
+          <p:cNvSpPr txBox="1"/>
+          <p:nvPr/>
+        </p:nvSpPr>
+        <p:spPr>
+          <a:xfrm>
+            <a:off x="3621024" y="2304288"/>
+            <a:ext cx="4005072" cy="566928"/>
+          </a:xfrm>
+          <a:prstGeom prst="rect">
+            <a:avLst/>
+          </a:prstGeom>
+          <a:noFill/>
+        </p:spPr>
+        <p:txBody>
+          <a:bodyPr wrap="square">
+            <a:spAutoFit/>
+          </a:bodyPr>
+          <a:lstStyle/>
+          <a:p>
+            <a:pPr algn="l">
+              <a:spcAft>
+                <a:spcPts val="400"/>
+              </a:spcAft>
+            </a:pPr>
+            <a:r>
+              <a:rPr sz="950" b="0" i="0">
+                <a:solidFill>
+                  <a:srgbClr val="1A1A1A"/>
+                </a:solidFill>
+                <a:latin typeface="Calibri"/>
+              </a:rPr>
+              <a:t>in-context learning works over DATA (unseen</a:t>
+            </a:r>
+          </a:p>
+          <a:p>
+            <a:pPr algn="l">
+              <a:spcAft>
+                <a:spcPts val="400"/>
+              </a:spcAft>
+            </a:pPr>
+            <a:r>
+              <a:rPr sz="950" b="0" i="0">
+                <a:solidFill>
+                  <a:srgbClr val="1A1A1A"/>
+                </a:solidFill>
+                <a:latin typeface="Calibri"/>
+              </a:rPr>
+              <a:t>basins) but NOT over TASKS</a:t>
+            </a:r>
+          </a:p>
+        </p:txBody>
+      </p:sp>
+      <p:sp>
+        <p:nvSpPr>
+          <p:cNvPr id="21" name="Rectangle 20"/>
+          <p:cNvSpPr/>
+          <p:nvPr/>
+        </p:nvSpPr>
+        <p:spPr>
+          <a:xfrm>
+            <a:off x="7680960" y="2276856"/>
+            <a:ext cx="4023360" cy="566928"/>
+          </a:xfrm>
+          <a:prstGeom prst="rect">
+            <a:avLst/>
+          </a:prstGeom>
+          <a:solidFill>
+            <a:srgbClr val="FFFFFF"/>
+          </a:solidFill>
+          <a:ln>
+            <a:noFill/>
+          </a:ln>
+          <a:effectLst/>
+        </p:spPr>
+        <p:style>
+          <a:lnRef idx="1">
+            <a:schemeClr val="accent1"/>
+          </a:lnRef>
+          <a:fillRef idx="3">
+            <a:schemeClr val="accent1"/>
+          </a:fillRef>
+          <a:effectRef idx="2">
+            <a:schemeClr val="accent1"/>
+          </a:effectRef>
+          <a:fontRef idx="minor">
+            <a:schemeClr val="lt1"/>
+          </a:fontRef>
+        </p:style>
+        <p:txBody>
+          <a:bodyPr rtlCol="0" anchor="ctr"/>
+          <a:lstStyle/>
+          <a:p/>
+        </p:txBody>
+      </p:sp>
+      <p:sp>
+        <p:nvSpPr>
+          <p:cNvPr id="22" name="TextBox 21"/>
+          <p:cNvSpPr txBox="1"/>
+          <p:nvPr/>
+        </p:nvSpPr>
+        <p:spPr>
+          <a:xfrm>
+            <a:off x="7735824" y="2304288"/>
+            <a:ext cx="3913632" cy="566928"/>
+          </a:xfrm>
+          <a:prstGeom prst="rect">
+            <a:avLst/>
+          </a:prstGeom>
+          <a:noFill/>
+        </p:spPr>
+        <p:txBody>
+          <a:bodyPr wrap="square">
+            <a:spAutoFit/>
+          </a:bodyPr>
+          <a:lstStyle/>
+          <a:p>
+            <a:pPr algn="l">
+              <a:spcAft>
+                <a:spcPts val="400"/>
+              </a:spcAft>
+            </a:pPr>
+            <a:r>
+              <a:rPr sz="950" b="0" i="0">
+                <a:solidFill>
+                  <a:srgbClr val="1A1A1A"/>
+                </a:solidFill>
+                <a:latin typeface="Calibri"/>
+              </a:rPr>
+              <a:t>self-as-context zero-shot 0.249 vs 0.698 control;</a:t>
+            </a:r>
+          </a:p>
+          <a:p>
+            <a:pPr algn="l">
+              <a:spcAft>
+                <a:spcPts val="400"/>
+              </a:spcAft>
+            </a:pPr>
+            <a:r>
+              <a:rPr sz="950" b="0" i="0">
+                <a:solidFill>
+                  <a:srgbClr val="1A1A1A"/>
+                </a:solidFill>
+                <a:latin typeface="Calibri"/>
+              </a:rPr>
+              <a:t>tcross stays at random init if never exercised</a:t>
+            </a:r>
+          </a:p>
+        </p:txBody>
+      </p:sp>
+      <p:sp>
+        <p:nvSpPr>
+          <p:cNvPr id="23" name="Rectangle 22"/>
+          <p:cNvSpPr/>
+          <p:nvPr/>
+        </p:nvSpPr>
+        <p:spPr>
+          <a:xfrm>
+            <a:off x="457200" y="2843784"/>
+            <a:ext cx="3108960" cy="566928"/>
+          </a:xfrm>
+          <a:prstGeom prst="rect">
+            <a:avLst/>
+          </a:prstGeom>
+          <a:solidFill>
+            <a:srgbClr val="F4F6F8"/>
+          </a:solidFill>
+          <a:ln>
+            <a:noFill/>
+          </a:ln>
+          <a:effectLst/>
+        </p:spPr>
+        <p:style>
+          <a:lnRef idx="1">
+            <a:schemeClr val="accent1"/>
+          </a:lnRef>
+          <a:fillRef idx="3">
+            <a:schemeClr val="accent1"/>
+          </a:fillRef>
+          <a:effectRef idx="2">
+            <a:schemeClr val="accent1"/>
+          </a:effectRef>
+          <a:fontRef idx="minor">
+            <a:schemeClr val="lt1"/>
+          </a:fontRef>
+        </p:style>
+        <p:txBody>
+          <a:bodyPr rtlCol="0" anchor="ctr"/>
+          <a:lstStyle/>
+          <a:p/>
+        </p:txBody>
+      </p:sp>
+      <p:sp>
+        <p:nvSpPr>
+          <p:cNvPr id="24" name="TextBox 23"/>
+          <p:cNvSpPr txBox="1"/>
+          <p:nvPr/>
+        </p:nvSpPr>
+        <p:spPr>
+          <a:xfrm>
+            <a:off x="512064" y="2871216"/>
+            <a:ext cx="2999232" cy="566928"/>
+          </a:xfrm>
+          <a:prstGeom prst="rect">
+            <a:avLst/>
+          </a:prstGeom>
+          <a:noFill/>
+        </p:spPr>
+        <p:txBody>
+          <a:bodyPr wrap="square">
+            <a:spAutoFit/>
+          </a:bodyPr>
+          <a:lstStyle/>
+          <a:p>
+            <a:pPr algn="l">
+              <a:spcAft>
+                <a:spcPts val="400"/>
+              </a:spcAft>
+            </a:pPr>
+            <a:r>
+              <a:rPr sz="950" b="0" i="0">
+                <a:solidFill>
+                  <a:srgbClr val="1A1A1A"/>
+                </a:solidFill>
+                <a:latin typeface="Calibri"/>
+              </a:rPr>
+              <a:t>Every conditional needs an ADEQUATE</a:t>
+            </a:r>
+          </a:p>
+          <a:p>
+            <a:pPr algn="l">
+              <a:spcAft>
+                <a:spcPts val="400"/>
+              </a:spcAft>
+            </a:pPr>
+            <a:r>
+              <a:rPr sz="950" b="0" i="0">
+                <a:solidFill>
+                  <a:srgbClr val="1A1A1A"/>
+                </a:solidFill>
+                <a:latin typeface="Calibri"/>
+              </a:rPr>
+              <a:t>SHARE of training, not mere presence</a:t>
+            </a:r>
+          </a:p>
+        </p:txBody>
+      </p:sp>
+      <p:sp>
+        <p:nvSpPr>
+          <p:cNvPr id="25" name="Rectangle 24"/>
+          <p:cNvSpPr/>
+          <p:nvPr/>
+        </p:nvSpPr>
+        <p:spPr>
+          <a:xfrm>
+            <a:off x="3566160" y="2843784"/>
+            <a:ext cx="4114800" cy="566928"/>
+          </a:xfrm>
+          <a:prstGeom prst="rect">
+            <a:avLst/>
+          </a:prstGeom>
+          <a:solidFill>
+            <a:srgbClr val="F4F6F8"/>
+          </a:solidFill>
+          <a:ln>
+            <a:noFill/>
+          </a:ln>
+          <a:effectLst/>
+        </p:spPr>
+        <p:style>
+          <a:lnRef idx="1">
+            <a:schemeClr val="accent1"/>
+          </a:lnRef>
+          <a:fillRef idx="3">
+            <a:schemeClr val="accent1"/>
+          </a:fillRef>
+          <a:effectRef idx="2">
+            <a:schemeClr val="accent1"/>
+          </a:effectRef>
+          <a:fontRef idx="minor">
+            <a:schemeClr val="lt1"/>
+          </a:fontRef>
+        </p:style>
+        <p:txBody>
+          <a:bodyPr rtlCol="0" anchor="ctr"/>
+          <a:lstStyle/>
+          <a:p/>
+        </p:txBody>
+      </p:sp>
+      <p:sp>
+        <p:nvSpPr>
+          <p:cNvPr id="26" name="TextBox 25"/>
+          <p:cNvSpPr txBox="1"/>
+          <p:nvPr/>
+        </p:nvSpPr>
+        <p:spPr>
+          <a:xfrm>
+            <a:off x="3621024" y="2871216"/>
+            <a:ext cx="4005072" cy="566928"/>
+          </a:xfrm>
+          <a:prstGeom prst="rect">
+            <a:avLst/>
+          </a:prstGeom>
+          <a:noFill/>
+        </p:spPr>
+        <p:txBody>
+          <a:bodyPr wrap="square">
+            <a:spAutoFit/>
+          </a:bodyPr>
+          <a:lstStyle/>
+          <a:p>
+            <a:pPr algn="l">
+              <a:spcAft>
+                <a:spcPts val="400"/>
+              </a:spcAft>
+            </a:pPr>
+            <a:r>
+              <a:rPr sz="950" b="0" i="0">
+                <a:solidFill>
+                  <a:srgbClr val="1A1A1A"/>
+                </a:solidFill>
+                <a:latin typeface="Calibri"/>
+              </a:rPr>
+              <a:t>a pathway always available gets relied on; one</a:t>
+            </a:r>
+          </a:p>
+          <a:p>
+            <a:pPr algn="l">
+              <a:spcAft>
+                <a:spcPts val="400"/>
+              </a:spcAft>
+            </a:pPr>
+            <a:r>
+              <a:rPr sz="950" b="0" i="0">
+                <a:solidFill>
+                  <a:srgbClr val="1A1A1A"/>
+                </a:solidFill>
+                <a:latin typeface="Calibri"/>
+              </a:rPr>
+              <a:t>that is starved never forms at all</a:t>
+            </a:r>
+          </a:p>
+        </p:txBody>
+      </p:sp>
+      <p:sp>
+        <p:nvSpPr>
+          <p:cNvPr id="27" name="Rectangle 26"/>
+          <p:cNvSpPr/>
+          <p:nvPr/>
+        </p:nvSpPr>
+        <p:spPr>
+          <a:xfrm>
+            <a:off x="7680960" y="2843784"/>
+            <a:ext cx="4023360" cy="566928"/>
+          </a:xfrm>
+          <a:prstGeom prst="rect">
+            <a:avLst/>
+          </a:prstGeom>
+          <a:solidFill>
+            <a:srgbClr val="F4F6F8"/>
+          </a:solidFill>
+          <a:ln>
+            <a:noFill/>
+          </a:ln>
+          <a:effectLst/>
+        </p:spPr>
+        <p:style>
+          <a:lnRef idx="1">
+            <a:schemeClr val="accent1"/>
+          </a:lnRef>
+          <a:fillRef idx="3">
+            <a:schemeClr val="accent1"/>
+          </a:fillRef>
+          <a:effectRef idx="2">
+            <a:schemeClr val="accent1"/>
+          </a:effectRef>
+          <a:fontRef idx="minor">
+            <a:schemeClr val="lt1"/>
+          </a:fontRef>
+        </p:style>
+        <p:txBody>
+          <a:bodyPr rtlCol="0" anchor="ctr"/>
+          <a:lstStyle/>
+          <a:p/>
+        </p:txBody>
+      </p:sp>
+      <p:sp>
+        <p:nvSpPr>
+          <p:cNvPr id="28" name="TextBox 27"/>
+          <p:cNvSpPr txBox="1"/>
+          <p:nvPr/>
+        </p:nvSpPr>
+        <p:spPr>
+          <a:xfrm>
+            <a:off x="7735824" y="2871216"/>
+            <a:ext cx="3913632" cy="566928"/>
+          </a:xfrm>
+          <a:prstGeom prst="rect">
+            <a:avLst/>
+          </a:prstGeom>
+          <a:noFill/>
+        </p:spPr>
+        <p:txBody>
+          <a:bodyPr wrap="square">
+            <a:spAutoFit/>
+          </a:bodyPr>
+          <a:lstStyle/>
+          <a:p>
+            <a:pPr algn="l">
+              <a:spcAft>
+                <a:spcPts val="400"/>
+              </a:spcAft>
+            </a:pPr>
+            <a:r>
+              <a:rPr sz="950" b="0" i="0">
+                <a:solidFill>
+                  <a:srgbClr val="1A1A1A"/>
+                </a:solidFill>
+                <a:latin typeface="Calibri"/>
+              </a:rPr>
+              <a:t>K=0 at 1/6 of tasks: 0.658. K=0-only: 0.7164.</a:t>
+            </a:r>
+          </a:p>
+          <a:p>
+            <a:pPr algn="l">
+              <a:spcAft>
+                <a:spcPts val="400"/>
+              </a:spcAft>
+            </a:pPr>
+            <a:r>
+              <a:rPr sz="950" b="0" i="0">
+                <a:solidFill>
+                  <a:srgbClr val="1A1A1A"/>
+                </a:solidFill>
+                <a:latin typeface="Calibri"/>
+              </a:rPr>
+              <a:t>Same default cost the DA task 0.17</a:t>
+            </a:r>
+          </a:p>
+        </p:txBody>
+      </p:sp>
+      <p:sp>
+        <p:nvSpPr>
+          <p:cNvPr id="29" name="Rectangle 28"/>
+          <p:cNvSpPr/>
+          <p:nvPr/>
+        </p:nvSpPr>
+        <p:spPr>
+          <a:xfrm>
+            <a:off x="457200" y="3410712"/>
+            <a:ext cx="3108960" cy="566928"/>
+          </a:xfrm>
+          <a:prstGeom prst="rect">
+            <a:avLst/>
+          </a:prstGeom>
+          <a:solidFill>
+            <a:srgbClr val="FFFFFF"/>
+          </a:solidFill>
+          <a:ln>
+            <a:noFill/>
+          </a:ln>
+          <a:effectLst/>
+        </p:spPr>
+        <p:style>
+          <a:lnRef idx="1">
+            <a:schemeClr val="accent1"/>
+          </a:lnRef>
+          <a:fillRef idx="3">
+            <a:schemeClr val="accent1"/>
+          </a:fillRef>
+          <a:effectRef idx="2">
+            <a:schemeClr val="accent1"/>
+          </a:effectRef>
+          <a:fontRef idx="minor">
+            <a:schemeClr val="lt1"/>
+          </a:fontRef>
+        </p:style>
+        <p:txBody>
+          <a:bodyPr rtlCol="0" anchor="ctr"/>
+          <a:lstStyle/>
+          <a:p/>
+        </p:txBody>
+      </p:sp>
+      <p:sp>
+        <p:nvSpPr>
+          <p:cNvPr id="30" name="TextBox 29"/>
+          <p:cNvSpPr txBox="1"/>
+          <p:nvPr/>
+        </p:nvSpPr>
+        <p:spPr>
+          <a:xfrm>
+            <a:off x="512064" y="3438144"/>
+            <a:ext cx="2999232" cy="566928"/>
+          </a:xfrm>
+          <a:prstGeom prst="rect">
+            <a:avLst/>
+          </a:prstGeom>
+          <a:noFill/>
+        </p:spPr>
+        <p:txBody>
+          <a:bodyPr wrap="square">
+            <a:spAutoFit/>
+          </a:bodyPr>
+          <a:lstStyle/>
+          <a:p>
+            <a:pPr algn="l">
+              <a:spcAft>
+                <a:spcPts val="400"/>
+              </a:spcAft>
+            </a:pPr>
+            <a:r>
+              <a:rPr sz="950" b="0" i="0">
+                <a:solidFill>
+                  <a:srgbClr val="1A1A1A"/>
+                </a:solidFill>
+                <a:latin typeface="Calibri"/>
+              </a:rPr>
+              <a:t>Causal masking, always</a:t>
+            </a:r>
+          </a:p>
+        </p:txBody>
+      </p:sp>
+      <p:sp>
+        <p:nvSpPr>
+          <p:cNvPr id="31" name="Rectangle 30"/>
+          <p:cNvSpPr/>
+          <p:nvPr/>
+        </p:nvSpPr>
+        <p:spPr>
+          <a:xfrm>
+            <a:off x="3566160" y="3410712"/>
+            <a:ext cx="4114800" cy="566928"/>
+          </a:xfrm>
+          <a:prstGeom prst="rect">
+            <a:avLst/>
+          </a:prstGeom>
+          <a:solidFill>
+            <a:srgbClr val="FFFFFF"/>
+          </a:solidFill>
+          <a:ln>
+            <a:noFill/>
+          </a:ln>
+          <a:effectLst/>
+        </p:spPr>
+        <p:style>
+          <a:lnRef idx="1">
+            <a:schemeClr val="accent1"/>
+          </a:lnRef>
+          <a:fillRef idx="3">
+            <a:schemeClr val="accent1"/>
+          </a:fillRef>
+          <a:effectRef idx="2">
+            <a:schemeClr val="accent1"/>
+          </a:effectRef>
+          <a:fontRef idx="minor">
+            <a:schemeClr val="lt1"/>
+          </a:fontRef>
+        </p:style>
+        <p:txBody>
+          <a:bodyPr rtlCol="0" anchor="ctr"/>
+          <a:lstStyle/>
+          <a:p/>
+        </p:txBody>
+      </p:sp>
+      <p:sp>
+        <p:nvSpPr>
+          <p:cNvPr id="32" name="TextBox 31"/>
+          <p:cNvSpPr txBox="1"/>
+          <p:nvPr/>
+        </p:nvSpPr>
+        <p:spPr>
+          <a:xfrm>
+            <a:off x="3621024" y="3438144"/>
+            <a:ext cx="4005072" cy="566928"/>
+          </a:xfrm>
+          <a:prstGeom prst="rect">
+            <a:avLst/>
+          </a:prstGeom>
+          <a:noFill/>
+        </p:spPr>
+        <p:txBody>
+          <a:bodyPr wrap="square">
+            <a:spAutoFit/>
+          </a:bodyPr>
+          <a:lstStyle/>
+          <a:p>
+            <a:pPr algn="l">
+              <a:spcAft>
+                <a:spcPts val="400"/>
+              </a:spcAft>
+            </a:pPr>
+            <a:r>
+              <a:rPr sz="950" b="0" i="0">
+                <a:solidFill>
+                  <a:srgbClr val="1A1A1A"/>
+                </a:solidFill>
+                <a:latin typeface="Calibri"/>
+              </a:rPr>
+              <a:t>free, and makes the model a filter not a smoother</a:t>
+            </a:r>
+          </a:p>
+          <a:p>
+            <a:pPr algn="l">
+              <a:spcAft>
+                <a:spcPts val="400"/>
+              </a:spcAft>
+            </a:pPr>
+            <a:r>
+              <a:rPr sz="950" b="0" i="0">
+                <a:solidFill>
+                  <a:srgbClr val="1A1A1A"/>
+                </a:solidFill>
+                <a:latin typeface="Calibri"/>
+              </a:rPr>
+              <a:t>-- required for any DA claim</a:t>
+            </a:r>
+          </a:p>
+        </p:txBody>
+      </p:sp>
+      <p:sp>
+        <p:nvSpPr>
+          <p:cNvPr id="33" name="Rectangle 32"/>
+          <p:cNvSpPr/>
+          <p:nvPr/>
+        </p:nvSpPr>
+        <p:spPr>
+          <a:xfrm>
+            <a:off x="7680960" y="3410712"/>
+            <a:ext cx="4023360" cy="566928"/>
+          </a:xfrm>
+          <a:prstGeom prst="rect">
+            <a:avLst/>
+          </a:prstGeom>
+          <a:solidFill>
+            <a:srgbClr val="FFFFFF"/>
+          </a:solidFill>
+          <a:ln>
+            <a:noFill/>
+          </a:ln>
+          <a:effectLst/>
+        </p:spPr>
+        <p:style>
+          <a:lnRef idx="1">
+            <a:schemeClr val="accent1"/>
+          </a:lnRef>
+          <a:fillRef idx="3">
+            <a:schemeClr val="accent1"/>
+          </a:fillRef>
+          <a:effectRef idx="2">
+            <a:schemeClr val="accent1"/>
+          </a:effectRef>
+          <a:fontRef idx="minor">
+            <a:schemeClr val="lt1"/>
+          </a:fontRef>
+        </p:style>
+        <p:txBody>
+          <a:bodyPr rtlCol="0" anchor="ctr"/>
+          <a:lstStyle/>
+          <a:p/>
+        </p:txBody>
+      </p:sp>
+      <p:sp>
+        <p:nvSpPr>
+          <p:cNvPr id="34" name="TextBox 33"/>
+          <p:cNvSpPr txBox="1"/>
+          <p:nvPr/>
+        </p:nvSpPr>
+        <p:spPr>
+          <a:xfrm>
+            <a:off x="7735824" y="3438144"/>
+            <a:ext cx="3913632" cy="566928"/>
+          </a:xfrm>
+          <a:prstGeom prst="rect">
+            <a:avLst/>
+          </a:prstGeom>
+          <a:noFill/>
+        </p:spPr>
+        <p:txBody>
+          <a:bodyPr wrap="square">
+            <a:spAutoFit/>
+          </a:bodyPr>
+          <a:lstStyle/>
+          <a:p>
+            <a:pPr algn="l">
+              <a:spcAft>
+                <a:spcPts val="400"/>
+              </a:spcAft>
+            </a:pPr>
+            <a:r>
+              <a:rPr sz="950" b="0" i="0">
+                <a:solidFill>
+                  <a:srgbClr val="1A1A1A"/>
+                </a:solidFill>
+                <a:latin typeface="Calibri"/>
+              </a:rPr>
+              <a:t>K=4: 0.837 -&gt; 0.846; large-K decay also reduced</a:t>
+            </a:r>
+          </a:p>
+        </p:txBody>
+      </p:sp>
+      <p:sp>
+        <p:nvSpPr>
+          <p:cNvPr id="35" name="Rectangle 34"/>
+          <p:cNvSpPr/>
+          <p:nvPr/>
+        </p:nvSpPr>
+        <p:spPr>
+          <a:xfrm>
+            <a:off x="457200" y="3977640"/>
+            <a:ext cx="3108960" cy="566928"/>
+          </a:xfrm>
+          <a:prstGeom prst="rect">
+            <a:avLst/>
+          </a:prstGeom>
+          <a:solidFill>
+            <a:srgbClr val="F4F6F8"/>
+          </a:solidFill>
+          <a:ln>
+            <a:noFill/>
+          </a:ln>
+          <a:effectLst/>
+        </p:spPr>
+        <p:style>
+          <a:lnRef idx="1">
+            <a:schemeClr val="accent1"/>
+          </a:lnRef>
+          <a:fillRef idx="3">
+            <a:schemeClr val="accent1"/>
+          </a:fillRef>
+          <a:effectRef idx="2">
+            <a:schemeClr val="accent1"/>
+          </a:effectRef>
+          <a:fontRef idx="minor">
+            <a:schemeClr val="lt1"/>
+          </a:fontRef>
+        </p:style>
+        <p:txBody>
+          <a:bodyPr rtlCol="0" anchor="ctr"/>
+          <a:lstStyle/>
+          <a:p/>
+        </p:txBody>
+      </p:sp>
+      <p:sp>
+        <p:nvSpPr>
+          <p:cNvPr id="36" name="TextBox 35"/>
+          <p:cNvSpPr txBox="1"/>
+          <p:nvPr/>
+        </p:nvSpPr>
+        <p:spPr>
+          <a:xfrm>
+            <a:off x="512064" y="4005072"/>
+            <a:ext cx="2999232" cy="566928"/>
+          </a:xfrm>
+          <a:prstGeom prst="rect">
+            <a:avLst/>
+          </a:prstGeom>
+          <a:noFill/>
+        </p:spPr>
+        <p:txBody>
+          <a:bodyPr wrap="square">
+            <a:spAutoFit/>
+          </a:bodyPr>
+          <a:lstStyle/>
+          <a:p>
+            <a:pPr algn="l">
+              <a:spcAft>
+                <a:spcPts val="400"/>
+              </a:spcAft>
+            </a:pPr>
+            <a:r>
+              <a:rPr sz="950" b="0" i="0">
+                <a:solidFill>
+                  <a:srgbClr val="1A1A1A"/>
+                </a:solidFill>
+                <a:latin typeface="Calibri"/>
+              </a:rPr>
+              <a:t>Geo-encoding on the TIME-ALIGNED path,</a:t>
+            </a:r>
+          </a:p>
+          <a:p>
+            <a:pPr algn="l">
+              <a:spcAft>
+                <a:spcPts val="400"/>
+              </a:spcAft>
+            </a:pPr>
+            <a:r>
+              <a:rPr sz="950" b="0" i="0">
+                <a:solidFill>
+                  <a:srgbClr val="1A1A1A"/>
+                </a:solidFill>
+                <a:latin typeface="Calibri"/>
+              </a:rPr>
+              <a:t>not the connector</a:t>
+            </a:r>
+          </a:p>
+        </p:txBody>
+      </p:sp>
+      <p:sp>
+        <p:nvSpPr>
+          <p:cNvPr id="37" name="Rectangle 36"/>
+          <p:cNvSpPr/>
+          <p:nvPr/>
+        </p:nvSpPr>
+        <p:spPr>
+          <a:xfrm>
+            <a:off x="3566160" y="3977640"/>
+            <a:ext cx="4114800" cy="566928"/>
+          </a:xfrm>
+          <a:prstGeom prst="rect">
+            <a:avLst/>
+          </a:prstGeom>
+          <a:solidFill>
+            <a:srgbClr val="F4F6F8"/>
+          </a:solidFill>
+          <a:ln>
+            <a:noFill/>
+          </a:ln>
+          <a:effectLst/>
+        </p:spPr>
+        <p:style>
+          <a:lnRef idx="1">
+            <a:schemeClr val="accent1"/>
+          </a:lnRef>
+          <a:fillRef idx="3">
+            <a:schemeClr val="accent1"/>
+          </a:fillRef>
+          <a:effectRef idx="2">
+            <a:schemeClr val="accent1"/>
+          </a:effectRef>
+          <a:fontRef idx="minor">
+            <a:schemeClr val="lt1"/>
+          </a:fontRef>
+        </p:style>
+        <p:txBody>
+          <a:bodyPr rtlCol="0" anchor="ctr"/>
+          <a:lstStyle/>
+          <a:p/>
+        </p:txBody>
+      </p:sp>
+      <p:sp>
+        <p:nvSpPr>
+          <p:cNvPr id="38" name="TextBox 37"/>
+          <p:cNvSpPr txBox="1"/>
+          <p:nvPr/>
+        </p:nvSpPr>
+        <p:spPr>
+          <a:xfrm>
+            <a:off x="3621024" y="4005072"/>
+            <a:ext cx="4005072" cy="566928"/>
+          </a:xfrm>
+          <a:prstGeom prst="rect">
+            <a:avLst/>
+          </a:prstGeom>
+          <a:noFill/>
+        </p:spPr>
+        <p:txBody>
+          <a:bodyPr wrap="square">
+            <a:spAutoFit/>
+          </a:bodyPr>
+          <a:lstStyle/>
+          <a:p>
+            <a:pPr algn="l">
+              <a:spcAft>
+                <a:spcPts val="400"/>
+              </a:spcAft>
+            </a:pPr>
+            <a:r>
+              <a:rPr sz="950" b="0" i="0">
+                <a:solidFill>
+                  <a:srgbClr val="1A1A1A"/>
+                </a:solidFill>
+                <a:latin typeface="Calibri"/>
+              </a:rPr>
+              <a:t>the connector carries almost no signal; context</a:t>
+            </a:r>
+          </a:p>
+          <a:p>
+            <a:pPr algn="l">
+              <a:spcAft>
+                <a:spcPts val="400"/>
+              </a:spcAft>
+            </a:pPr>
+            <a:r>
+              <a:rPr sz="950" b="0" i="0">
+                <a:solidFill>
+                  <a:srgbClr val="1A1A1A"/>
+                </a:solidFill>
+                <a:latin typeface="Calibri"/>
+              </a:rPr>
+              <a:t>is actually mixed in tcross</a:t>
+            </a:r>
+          </a:p>
+        </p:txBody>
+      </p:sp>
+      <p:sp>
+        <p:nvSpPr>
+          <p:cNvPr id="39" name="Rectangle 38"/>
+          <p:cNvSpPr/>
+          <p:nvPr/>
+        </p:nvSpPr>
+        <p:spPr>
+          <a:xfrm>
+            <a:off x="7680960" y="3977640"/>
+            <a:ext cx="4023360" cy="566928"/>
+          </a:xfrm>
+          <a:prstGeom prst="rect">
+            <a:avLst/>
+          </a:prstGeom>
+          <a:solidFill>
+            <a:srgbClr val="F4F6F8"/>
+          </a:solidFill>
+          <a:ln>
+            <a:noFill/>
+          </a:ln>
+          <a:effectLst/>
+        </p:spPr>
+        <p:style>
+          <a:lnRef idx="1">
+            <a:schemeClr val="accent1"/>
+          </a:lnRef>
+          <a:fillRef idx="3">
+            <a:schemeClr val="accent1"/>
+          </a:fillRef>
+          <a:effectRef idx="2">
+            <a:schemeClr val="accent1"/>
+          </a:effectRef>
+          <a:fontRef idx="minor">
+            <a:schemeClr val="lt1"/>
+          </a:fontRef>
+        </p:style>
+        <p:txBody>
+          <a:bodyPr rtlCol="0" anchor="ctr"/>
+          <a:lstStyle/>
+          <a:p/>
+        </p:txBody>
+      </p:sp>
+      <p:sp>
+        <p:nvSpPr>
+          <p:cNvPr id="40" name="TextBox 39"/>
+          <p:cNvSpPr txBox="1"/>
+          <p:nvPr/>
+        </p:nvSpPr>
+        <p:spPr>
+          <a:xfrm>
+            <a:off x="7735824" y="4005072"/>
+            <a:ext cx="3913632" cy="566928"/>
+          </a:xfrm>
+          <a:prstGeom prst="rect">
+            <a:avLst/>
+          </a:prstGeom>
+          <a:noFill/>
+        </p:spPr>
+        <p:txBody>
+          <a:bodyPr wrap="square">
+            <a:spAutoFit/>
+          </a:bodyPr>
+          <a:lstStyle/>
+          <a:p>
+            <a:pPr algn="l">
+              <a:spcAft>
+                <a:spcPts val="400"/>
+              </a:spcAft>
+            </a:pPr>
+            <a:r>
+              <a:rPr sz="950" b="0" i="0">
+                <a:solidFill>
+                  <a:srgbClr val="1A1A1A"/>
+                </a:solidFill>
+                <a:latin typeface="Calibri"/>
+              </a:rPr>
+              <a:t>connector contributes 0.001. Moved: K=32 goes</a:t>
+            </a:r>
+          </a:p>
+          <a:p>
+            <a:pPr algn="l">
+              <a:spcAft>
+                <a:spcPts val="400"/>
+              </a:spcAft>
+            </a:pPr>
+            <a:r>
+              <a:rPr sz="950" b="0" i="0">
+                <a:solidFill>
+                  <a:srgbClr val="1A1A1A"/>
+                </a:solidFill>
+                <a:latin typeface="Calibri"/>
+              </a:rPr>
+              <a:t>0.828 -&gt; 0.846, flat from K=4 onward</a:t>
+            </a:r>
+          </a:p>
+        </p:txBody>
+      </p:sp>
+      <p:sp>
+        <p:nvSpPr>
+          <p:cNvPr id="41" name="Rectangle 40"/>
+          <p:cNvSpPr/>
+          <p:nvPr/>
+        </p:nvSpPr>
+        <p:spPr>
+          <a:xfrm>
+            <a:off x="457200" y="4544568"/>
+            <a:ext cx="3108960" cy="566928"/>
+          </a:xfrm>
+          <a:prstGeom prst="rect">
+            <a:avLst/>
+          </a:prstGeom>
+          <a:solidFill>
+            <a:srgbClr val="FFFFFF"/>
+          </a:solidFill>
+          <a:ln>
+            <a:noFill/>
+          </a:ln>
+          <a:effectLst/>
+        </p:spPr>
+        <p:style>
+          <a:lnRef idx="1">
+            <a:schemeClr val="accent1"/>
+          </a:lnRef>
+          <a:fillRef idx="3">
+            <a:schemeClr val="accent1"/>
+          </a:fillRef>
+          <a:effectRef idx="2">
+            <a:schemeClr val="accent1"/>
+          </a:effectRef>
+          <a:fontRef idx="minor">
+            <a:schemeClr val="lt1"/>
+          </a:fontRef>
+        </p:style>
+        <p:txBody>
+          <a:bodyPr rtlCol="0" anchor="ctr"/>
+          <a:lstStyle/>
+          <a:p/>
+        </p:txBody>
+      </p:sp>
+      <p:sp>
+        <p:nvSpPr>
+          <p:cNvPr id="42" name="TextBox 41"/>
+          <p:cNvSpPr txBox="1"/>
+          <p:nvPr/>
+        </p:nvSpPr>
+        <p:spPr>
+          <a:xfrm>
+            <a:off x="512064" y="4572000"/>
+            <a:ext cx="2999232" cy="566928"/>
+          </a:xfrm>
+          <a:prstGeom prst="rect">
+            <a:avLst/>
+          </a:prstGeom>
+          <a:noFill/>
+        </p:spPr>
+        <p:txBody>
+          <a:bodyPr wrap="square">
+            <a:spAutoFit/>
+          </a:bodyPr>
+          <a:lstStyle/>
+          <a:p>
+            <a:pPr algn="l">
+              <a:spcAft>
+                <a:spcPts val="400"/>
+              </a:spcAft>
+            </a:pPr>
+            <a:r>
+              <a:rPr sz="950" b="0" i="0">
+                <a:solidFill>
+                  <a:srgbClr val="1A1A1A"/>
+                </a:solidFill>
+                <a:latin typeface="Calibri"/>
+              </a:rPr>
+              <a:t>Prefer DEM over curated statics</a:t>
+            </a:r>
+          </a:p>
+          <a:p>
+            <a:pPr algn="l">
+              <a:spcAft>
+                <a:spcPts val="400"/>
+              </a:spcAft>
+            </a:pPr>
+            <a:r>
+              <a:rPr sz="950" b="0" i="0">
+                <a:solidFill>
+                  <a:srgbClr val="1A1A1A"/>
+                </a:solidFill>
+                <a:latin typeface="Calibri"/>
+              </a:rPr>
+              <a:t>(NOT YET IMPLEMENTED)</a:t>
+            </a:r>
+          </a:p>
+        </p:txBody>
+      </p:sp>
+      <p:sp>
+        <p:nvSpPr>
+          <p:cNvPr id="43" name="Rectangle 42"/>
+          <p:cNvSpPr/>
+          <p:nvPr/>
+        </p:nvSpPr>
+        <p:spPr>
+          <a:xfrm>
+            <a:off x="3566160" y="4544568"/>
+            <a:ext cx="4114800" cy="566928"/>
+          </a:xfrm>
+          <a:prstGeom prst="rect">
+            <a:avLst/>
+          </a:prstGeom>
+          <a:solidFill>
+            <a:srgbClr val="FFFFFF"/>
+          </a:solidFill>
+          <a:ln>
+            <a:noFill/>
+          </a:ln>
+          <a:effectLst/>
+        </p:spPr>
+        <p:style>
+          <a:lnRef idx="1">
+            <a:schemeClr val="accent1"/>
+          </a:lnRef>
+          <a:fillRef idx="3">
+            <a:schemeClr val="accent1"/>
+          </a:fillRef>
+          <a:effectRef idx="2">
+            <a:schemeClr val="accent1"/>
+          </a:effectRef>
+          <a:fontRef idx="minor">
+            <a:schemeClr val="lt1"/>
+          </a:fontRef>
+        </p:style>
+        <p:txBody>
+          <a:bodyPr rtlCol="0" anchor="ctr"/>
+          <a:lstStyle/>
+          <a:p/>
+        </p:txBody>
+      </p:sp>
+      <p:sp>
+        <p:nvSpPr>
+          <p:cNvPr id="44" name="TextBox 43"/>
+          <p:cNvSpPr txBox="1"/>
+          <p:nvPr/>
+        </p:nvSpPr>
+        <p:spPr>
+          <a:xfrm>
+            <a:off x="3621024" y="4572000"/>
+            <a:ext cx="4005072" cy="566928"/>
+          </a:xfrm>
+          <a:prstGeom prst="rect">
+            <a:avLst/>
+          </a:prstGeom>
+          <a:noFill/>
+        </p:spPr>
+        <p:txBody>
+          <a:bodyPr wrap="square">
+            <a:spAutoFit/>
+          </a:bodyPr>
+          <a:lstStyle/>
+          <a:p>
+            <a:pPr algn="l">
+              <a:spcAft>
+                <a:spcPts val="400"/>
+              </a:spcAft>
+            </a:pPr>
+            <a:r>
+              <a:rPr sz="950" b="0" i="0">
+                <a:solidFill>
+                  <a:srgbClr val="1A1A1A"/>
+                </a:solidFill>
+                <a:latin typeface="Calibri"/>
+              </a:rPr>
+              <a:t>curated attributes win in-distribution and fail</a:t>
+            </a:r>
+          </a:p>
+          <a:p>
+            <a:pPr algn="l">
+              <a:spcAft>
+                <a:spcPts val="400"/>
+              </a:spcAft>
+            </a:pPr>
+            <a:r>
+              <a:rPr sz="950" b="0" i="0">
+                <a:solidFill>
+                  <a:srgbClr val="1A1A1A"/>
+                </a:solidFill>
+                <a:latin typeface="Calibri"/>
+              </a:rPr>
+              <a:t>globally; DEM is the consistent input</a:t>
+            </a:r>
+          </a:p>
+        </p:txBody>
+      </p:sp>
+      <p:sp>
+        <p:nvSpPr>
+          <p:cNvPr id="45" name="Rectangle 44"/>
+          <p:cNvSpPr/>
+          <p:nvPr/>
+        </p:nvSpPr>
+        <p:spPr>
+          <a:xfrm>
+            <a:off x="7680960" y="4544568"/>
+            <a:ext cx="4023360" cy="566928"/>
+          </a:xfrm>
+          <a:prstGeom prst="rect">
+            <a:avLst/>
+          </a:prstGeom>
+          <a:solidFill>
+            <a:srgbClr val="FFFFFF"/>
+          </a:solidFill>
+          <a:ln>
+            <a:noFill/>
+          </a:ln>
+          <a:effectLst/>
+        </p:spPr>
+        <p:style>
+          <a:lnRef idx="1">
+            <a:schemeClr val="accent1"/>
+          </a:lnRef>
+          <a:fillRef idx="3">
+            <a:schemeClr val="accent1"/>
+          </a:fillRef>
+          <a:effectRef idx="2">
+            <a:schemeClr val="accent1"/>
+          </a:effectRef>
+          <a:fontRef idx="minor">
+            <a:schemeClr val="lt1"/>
+          </a:fontRef>
+        </p:style>
+        <p:txBody>
+          <a:bodyPr rtlCol="0" anchor="ctr"/>
+          <a:lstStyle/>
+          <a:p/>
+        </p:txBody>
+      </p:sp>
+      <p:sp>
+        <p:nvSpPr>
+          <p:cNvPr id="46" name="TextBox 45"/>
+          <p:cNvSpPr txBox="1"/>
+          <p:nvPr/>
+        </p:nvSpPr>
+        <p:spPr>
+          <a:xfrm>
+            <a:off x="7735824" y="4572000"/>
+            <a:ext cx="3913632" cy="566928"/>
+          </a:xfrm>
+          <a:prstGeom prst="rect">
+            <a:avLst/>
+          </a:prstGeom>
+          <a:noFill/>
+        </p:spPr>
+        <p:txBody>
+          <a:bodyPr wrap="square">
+            <a:spAutoFit/>
+          </a:bodyPr>
+          <a:lstStyle/>
+          <a:p>
+            <a:pPr algn="l">
+              <a:spcAft>
+                <a:spcPts val="400"/>
+              </a:spcAft>
+            </a:pPr>
+            <a:r>
+              <a:rPr sz="950" b="0" i="0">
+                <a:solidFill>
+                  <a:srgbClr val="1A1A1A"/>
+                </a:solidFill>
+                <a:latin typeface="Calibri"/>
+              </a:rPr>
+              <a:t>untested. Ablating statics at inference would</a:t>
+            </a:r>
+          </a:p>
+          <a:p>
+            <a:pPr algn="l">
+              <a:spcAft>
+                <a:spcPts val="400"/>
+              </a:spcAft>
+            </a:pPr>
+            <a:r>
+              <a:rPr sz="950" b="0" i="0">
+                <a:solidFill>
+                  <a:srgbClr val="1A1A1A"/>
+                </a:solidFill>
+                <a:latin typeface="Calibri"/>
+              </a:rPr>
+              <a:t>measure the transfer risk directly</a:t>
+            </a:r>
+          </a:p>
+        </p:txBody>
+      </p:sp>
+      <p:sp>
+        <p:nvSpPr>
+          <p:cNvPr id="47" name="Rounded Rectangle 46"/>
+          <p:cNvSpPr/>
+          <p:nvPr/>
+        </p:nvSpPr>
+        <p:spPr>
+          <a:xfrm>
+            <a:off x="457200" y="5029200"/>
+            <a:ext cx="11247120" cy="914400"/>
+          </a:xfrm>
+          <a:prstGeom prst="roundRect">
+            <a:avLst/>
+          </a:prstGeom>
+          <a:solidFill>
+            <a:srgbClr val="F4F6F8"/>
+          </a:solidFill>
+          <a:ln w="15875">
+            <a:solidFill>
+              <a:srgbClr val="0B5F8A"/>
+            </a:solidFill>
+          </a:ln>
+          <a:effectLst/>
+        </p:spPr>
+        <p:style>
+          <a:lnRef idx="1">
+            <a:schemeClr val="accent1"/>
+          </a:lnRef>
+          <a:fillRef idx="3">
+            <a:schemeClr val="accent1"/>
+          </a:fillRef>
+          <a:effectRef idx="2">
+            <a:schemeClr val="accent1"/>
+          </a:effectRef>
+          <a:fontRef idx="minor">
+            <a:schemeClr val="lt1"/>
+          </a:fontRef>
+        </p:style>
+        <p:txBody>
+          <a:bodyPr rtlCol="0" anchor="ctr"/>
+          <a:lstStyle/>
+          <a:p/>
+        </p:txBody>
+      </p:sp>
+      <p:sp>
+        <p:nvSpPr>
+          <p:cNvPr id="48" name="TextBox 47"/>
+          <p:cNvSpPr txBox="1"/>
+          <p:nvPr/>
+        </p:nvSpPr>
+        <p:spPr>
+          <a:xfrm>
+            <a:off x="640080" y="5138928"/>
+            <a:ext cx="10881360" cy="777240"/>
+          </a:xfrm>
+          <a:prstGeom prst="rect">
+            <a:avLst/>
+          </a:prstGeom>
+          <a:noFill/>
+        </p:spPr>
+        <p:txBody>
+          <a:bodyPr wrap="square">
+            <a:spAutoFit/>
+          </a:bodyPr>
+          <a:lstStyle/>
+          <a:p>
+            <a:pPr algn="l">
+              <a:spcAft>
+                <a:spcPts val="400"/>
+              </a:spcAft>
+            </a:pPr>
+            <a:r>
+              <a:rPr sz="1250" b="0" i="0">
+                <a:solidFill>
+                  <a:srgbClr val="1A1A1A"/>
+                </a:solidFill>
+                <a:latin typeface="Calibri"/>
+              </a:rPr>
+              <a:t>One pattern behind all six: a capability the model is never asked for during pretraining does not exist at inference,</a:t>
+            </a:r>
+          </a:p>
+          <a:p>
+            <a:pPr algn="l">
+              <a:spcAft>
+                <a:spcPts val="400"/>
+              </a:spcAft>
+            </a:pPr>
+            <a:r>
+              <a:rPr sz="1250" b="0" i="0">
+                <a:solidFill>
+                  <a:srgbClr val="1A1A1A"/>
+                </a:solidFill>
+                <a:latin typeface="Calibri"/>
+              </a:rPr>
+              <a:t>and one it is only occasionally asked for exists weakly. Scale (671 -&gt; ~40,000 stations) changes the budget, not this rule.</a:t>
+            </a:r>
+          </a:p>
+        </p:txBody>
+      </p:sp>
+    </p:spTree>
+  </p:cSld>
+  <p:clrMapOvr>
+    <a:masterClrMapping/>
+  </p:clrMapOvr>
+</p:sld>
+</file>
+
 <file path=ppt/slides/slide2.xml><?xml version="1.0" encoding="utf-8"?>
 <p:sld xmlns:a="http://schemas.openxmlformats.org/drawingml/2006/main" xmlns:p="http://schemas.openxmlformats.org/presentationml/2006/main" xmlns:r="http://schemas.openxmlformats.org/officeDocument/2006/relationships">
   <p:cSld>
@@ -20927,7 +23122,7 @@
                 </a:solidFill>
                 <a:latin typeface="Calibri"/>
               </a:rPr>
-              <a:t>1</a:t>
+              <a:t>1..a</a:t>
             </a:r>
           </a:p>
         </p:txBody>
@@ -21089,7 +23284,7 @@
                 </a:solidFill>
                 <a:latin typeface="Calibri"/>
               </a:rPr>
-              <a:t>MLP(18 attributes)</a:t>
+              <a:t>ONE TOKEN PER ATTRIBUTE: attr-ID emb + value</a:t>
             </a:r>
           </a:p>
         </p:txBody>
@@ -22304,7 +24499,7 @@
                 </a:solidFill>
                 <a:latin typeface="Calibri"/>
               </a:rPr>
-              <a:t>MLP(18 attributes)</a:t>
+              <a:t>one token per attribute, same ID space</a:t>
             </a:r>
           </a:p>
         </p:txBody>

</xml_diff>